<commit_message>
Final description (986 chars) and deck with audio/voice ingest
Co-Authored-By: Claude Opus 5.5 <noreply@anthropic.com>
</commit_message>
<xml_diff>
--- a/deck/canon-deck.pptx
+++ b/deck/canon-deck.pptx
@@ -11126,7 +11126,7 @@
                 </a:solidFill>
                 <a:latin typeface="Google Sans Flex"/>
               </a:rPr>
-              <a:t>- Extracts decisions with verified quotes from chats, meetings, wiki, PRs, PDFs and screenshots.</a:t>
+              <a:t>- Extracts decisions with verified quotes from chats, meetings, wiki, PRs, PDFs, screenshots and voice recordings.</a:t>
             </a:r>
           </a:p>
           <a:p>
@@ -11523,7 +11523,7 @@
                 </a:solidFill>
                 <a:latin typeface="Google Sans Flex"/>
               </a:rPr>
-              <a:t>Slack, meetings, wiki, PRs, commits, email, paste, PDFs and screenshots (Gemini reads them).</a:t>
+              <a:t>Slack, meetings, wiki, PRs, commits, email, paste, PDFs, screenshots, audio and video (Gemini reads them; 10 min audio, 2 min video, 30 min a day).</a:t>
             </a:r>
           </a:p>
           <a:p>
@@ -11771,7 +11771,7 @@
                 </a:solidFill>
                 <a:latin typeface="Google Sans Flex"/>
               </a:rPr>
-              <a:t>synced every minute (threads, files, PDFs, screenshots); replies under the message; /canon ask, check, catchup, remember.</a:t>
+              <a:t>synced every minute (threads, files, PDFs, screenshots, voice notes); replies under the message; /canon ask, check, catchup, remember.</a:t>
             </a:r>
           </a:p>
           <a:p>

</xml_diff>

<commit_message>
deck: Live in Discord slide with real server screenshots
Co-Authored-By: Claude Opus 5.5 <noreply@anthropic.com>
</commit_message>
<xml_diff>
--- a/deck/canon-deck.pptx
+++ b/deck/canon-deck.pptx
@@ -18,6 +18,7 @@
     <p:sldId id="264" r:id="rId14"/>
     <p:sldId id="265" r:id="rId15"/>
     <p:sldId id="266" r:id="rId16"/>
+    <p:sldId id="272" r:id="rId20"/>
     <p:sldId id="267" r:id="rId17"/>
     <p:sldId id="268" r:id="rId18"/>
     <p:sldId id="269" r:id="rId19"/>
@@ -10289,6 +10290,353 @@
           </a:prstGeom>
         </p:spPr>
       </p:pic>
+    </p:spTree>
+  </p:cSld>
+  <p:clrMapOvr>
+    <a:masterClrMapping/>
+  </p:clrMapOvr>
+</p:sld>
+</file>
+
+<file path=ppt/slides/slide15.xml><?xml version="1.0" encoding="utf-8"?>
+<p:sld xmlns:a="http://schemas.openxmlformats.org/drawingml/2006/main" xmlns:p="http://schemas.openxmlformats.org/presentationml/2006/main" xmlns:r="http://schemas.openxmlformats.org/officeDocument/2006/relationships">
+  <p:cSld>
+    <p:spTree>
+      <p:nvGrpSpPr>
+        <p:cNvPr id="1" name=""/>
+        <p:cNvGrpSpPr/>
+        <p:nvPr/>
+      </p:nvGrpSpPr>
+      <p:grpSpPr/>
+      <p:sp>
+        <p:nvSpPr>
+          <p:cNvPr id="2" name="Title 1"/>
+          <p:cNvSpPr>
+            <a:spLocks noGrp="1"/>
+          </p:cNvSpPr>
+          <p:nvPr>
+            <p:ph type="ctrTitle"/>
+          </p:nvPr>
+        </p:nvSpPr>
+        <p:spPr/>
+        <p:txBody>
+          <a:bodyPr/>
+          <a:lstStyle/>
+          <a:p/>
+        </p:txBody>
+      </p:sp>
+      <p:sp>
+        <p:nvSpPr>
+          <p:cNvPr id="3" name="Subtitle 2"/>
+          <p:cNvSpPr>
+            <a:spLocks noGrp="1"/>
+          </p:cNvSpPr>
+          <p:nvPr>
+            <p:ph type="subTitle" idx="1"/>
+          </p:nvPr>
+        </p:nvSpPr>
+        <p:spPr/>
+        <p:txBody>
+          <a:bodyPr/>
+          <a:lstStyle/>
+          <a:p/>
+        </p:txBody>
+      </p:sp>
+      <p:sp>
+        <p:nvSpPr>
+          <p:cNvPr id="135" name="Google Shape;135;p23"/>
+          <p:cNvSpPr txBox="1"/>
+          <p:nvPr/>
+        </p:nvSpPr>
+        <p:spPr>
+          <a:xfrm>
+            <a:off x="265350" y="663825"/>
+            <a:ext cx="8943000" cy="548640"/>
+          </a:xfrm>
+          <a:prstGeom prst="rect">
+            <a:avLst/>
+          </a:prstGeom>
+          <a:noFill/>
+          <a:ln>
+            <a:noFill/>
+          </a:ln>
+        </p:spPr>
+        <p:txBody>
+          <a:bodyPr anchorCtr="0" anchor="t" bIns="91425" lIns="91425" spcFirstLastPara="1" rIns="91425" wrap="square" tIns="91425">
+            <a:noAutofit/>
+          </a:bodyPr>
+          <a:lstStyle/>
+          <a:p>
+            <a:pPr indent="0" lvl="0" marL="0" rtl="0" algn="l">
+              <a:spcBef>
+                <a:spcPts val="0"/>
+              </a:spcBef>
+              <a:spcAft>
+                <a:spcPts val="0"/>
+              </a:spcAft>
+              <a:buNone/>
+            </a:pPr>
+            <a:r>
+              <a:rPr lang="en-GB" sz="1600">
+                <a:latin typeface="Google Sans Flex Medium"/>
+                <a:ea typeface="Google Sans Flex Medium"/>
+                <a:cs typeface="Google Sans Flex Medium"/>
+                <a:sym typeface="Google Sans Flex Medium"/>
+              </a:rPr>
+              <a:t>Live in Discord: Canon learns from a real server</a:t>
+            </a:r>
+            <a:endParaRPr sz="1600">
+              <a:latin typeface="Google Sans Flex Medium"/>
+              <a:ea typeface="Google Sans Flex Medium"/>
+              <a:cs typeface="Google Sans Flex Medium"/>
+              <a:sym typeface="Google Sans Flex Medium"/>
+            </a:endParaRPr>
+          </a:p>
+        </p:txBody>
+      </p:sp>
+      <p:pic>
+        <p:nvPicPr>
+          <p:cNvPr id="136" name="Picture 135" descr="1-general.jpg"/>
+          <p:cNvPicPr>
+            <a:picLocks noChangeAspect="1"/>
+          </p:cNvPicPr>
+          <p:nvPr/>
+        </p:nvPicPr>
+        <p:blipFill>
+          <a:blip r:embed="rId2"/>
+          <a:stretch>
+            <a:fillRect/>
+          </a:stretch>
+        </p:blipFill>
+        <p:spPr>
+          <a:xfrm>
+            <a:off x="320040" y="1455855"/>
+            <a:ext cx="2743200" cy="1340249"/>
+          </a:xfrm>
+          <a:prstGeom prst="rect">
+            <a:avLst/>
+          </a:prstGeom>
+          <a:ln w="9525">
+            <a:solidFill>
+              <a:srgbClr val="D8CFBE"/>
+            </a:solidFill>
+          </a:ln>
+        </p:spPr>
+      </p:pic>
+      <p:sp>
+        <p:nvSpPr>
+          <p:cNvPr id="137" name="TextBox 136"/>
+          <p:cNvSpPr txBox="1"/>
+          <p:nvPr/>
+        </p:nvSpPr>
+        <p:spPr>
+          <a:xfrm>
+            <a:off x="320040" y="3063239"/>
+            <a:ext cx="2743200" cy="274320"/>
+          </a:xfrm>
+          <a:prstGeom prst="rect">
+            <a:avLst/>
+          </a:prstGeom>
+          <a:noFill/>
+        </p:spPr>
+        <p:txBody>
+          <a:bodyPr wrap="square" anchor="t" lIns="45720" rIns="45720">
+            <a:spAutoFit/>
+          </a:bodyPr>
+          <a:lstStyle/>
+          <a:p>
+            <a:pPr algn="ctr">
+              <a:spcAft>
+                <a:spcPts val="400"/>
+              </a:spcAft>
+            </a:pPr>
+            <a:r>
+              <a:rPr sz="900" b="0">
+                <a:solidFill>
+                  <a:srgbClr val="5F5A52"/>
+                </a:solidFill>
+                <a:latin typeface="Google Sans Flex"/>
+              </a:rPr>
+              <a:t>Threads in #general, posted as the people who wrote them</a:t>
+            </a:r>
+          </a:p>
+        </p:txBody>
+      </p:sp>
+      <p:pic>
+        <p:nvPicPr>
+          <p:cNvPr id="138" name="Picture 137" descr="2-engineering.jpg"/>
+          <p:cNvPicPr>
+            <a:picLocks noChangeAspect="1"/>
+          </p:cNvPicPr>
+          <p:nvPr/>
+        </p:nvPicPr>
+        <p:blipFill>
+          <a:blip r:embed="rId3"/>
+          <a:stretch>
+            <a:fillRect/>
+          </a:stretch>
+        </p:blipFill>
+        <p:spPr>
+          <a:xfrm>
+            <a:off x="3200400" y="1461733"/>
+            <a:ext cx="2743200" cy="1328492"/>
+          </a:xfrm>
+          <a:prstGeom prst="rect">
+            <a:avLst/>
+          </a:prstGeom>
+          <a:ln w="9525">
+            <a:solidFill>
+              <a:srgbClr val="D8CFBE"/>
+            </a:solidFill>
+          </a:ln>
+        </p:spPr>
+      </p:pic>
+      <p:sp>
+        <p:nvSpPr>
+          <p:cNvPr id="139" name="TextBox 138"/>
+          <p:cNvSpPr txBox="1"/>
+          <p:nvPr/>
+        </p:nvSpPr>
+        <p:spPr>
+          <a:xfrm>
+            <a:off x="3200400" y="3063239"/>
+            <a:ext cx="2743200" cy="274320"/>
+          </a:xfrm>
+          <a:prstGeom prst="rect">
+            <a:avLst/>
+          </a:prstGeom>
+          <a:noFill/>
+        </p:spPr>
+        <p:txBody>
+          <a:bodyPr wrap="square" anchor="t" lIns="45720" rIns="45720">
+            <a:spAutoFit/>
+          </a:bodyPr>
+          <a:lstStyle/>
+          <a:p>
+            <a:pPr algn="ctr">
+              <a:spcAft>
+                <a:spcPts val="400"/>
+              </a:spcAft>
+            </a:pPr>
+            <a:r>
+              <a:rPr sz="900" b="0">
+                <a:solidFill>
+                  <a:srgbClr val="5F5A52"/>
+                </a:solidFill>
+                <a:latin typeface="Google Sans Flex"/>
+              </a:rPr>
+              <a:t>#engineering: the stale Friday release window, as a screenshot</a:t>
+            </a:r>
+          </a:p>
+        </p:txBody>
+      </p:sp>
+      <p:pic>
+        <p:nvPicPr>
+          <p:cNvPr id="140" name="Picture 139" descr="3-sales.jpg"/>
+          <p:cNvPicPr>
+            <a:picLocks noChangeAspect="1"/>
+          </p:cNvPicPr>
+          <p:nvPr/>
+        </p:nvPicPr>
+        <p:blipFill>
+          <a:blip r:embed="rId4"/>
+          <a:stretch>
+            <a:fillRect/>
+          </a:stretch>
+        </p:blipFill>
+        <p:spPr>
+          <a:xfrm>
+            <a:off x="6080760" y="1343188"/>
+            <a:ext cx="2743200" cy="1565583"/>
+          </a:xfrm>
+          <a:prstGeom prst="rect">
+            <a:avLst/>
+          </a:prstGeom>
+          <a:ln w="9525">
+            <a:solidFill>
+              <a:srgbClr val="D8CFBE"/>
+            </a:solidFill>
+          </a:ln>
+        </p:spPr>
+      </p:pic>
+      <p:sp>
+        <p:nvSpPr>
+          <p:cNvPr id="141" name="TextBox 140"/>
+          <p:cNvSpPr txBox="1"/>
+          <p:nvPr/>
+        </p:nvSpPr>
+        <p:spPr>
+          <a:xfrm>
+            <a:off x="6080760" y="3063239"/>
+            <a:ext cx="2743200" cy="274320"/>
+          </a:xfrm>
+          <a:prstGeom prst="rect">
+            <a:avLst/>
+          </a:prstGeom>
+          <a:noFill/>
+        </p:spPr>
+        <p:txBody>
+          <a:bodyPr wrap="square" anchor="t" lIns="45720" rIns="45720">
+            <a:spAutoFit/>
+          </a:bodyPr>
+          <a:lstStyle/>
+          <a:p>
+            <a:pPr algn="ctr">
+              <a:spcAft>
+                <a:spcPts val="400"/>
+              </a:spcAft>
+            </a:pPr>
+            <a:r>
+              <a:rPr sz="900" b="0">
+                <a:solidFill>
+                  <a:srgbClr val="5F5A52"/>
+                </a:solidFill>
+                <a:latin typeface="Google Sans Flex"/>
+              </a:rPr>
+              <a:t>#sales: the old USD 99 pricing page and the sales FAQ file</a:t>
+            </a:r>
+          </a:p>
+        </p:txBody>
+      </p:sp>
+      <p:sp>
+        <p:nvSpPr>
+          <p:cNvPr id="142" name="TextBox 141"/>
+          <p:cNvSpPr txBox="1"/>
+          <p:nvPr/>
+        </p:nvSpPr>
+        <p:spPr>
+          <a:xfrm>
+            <a:off x="320040" y="3520440"/>
+            <a:ext cx="8503920" cy="548640"/>
+          </a:xfrm>
+          <a:prstGeom prst="rect">
+            <a:avLst/>
+          </a:prstGeom>
+          <a:noFill/>
+        </p:spPr>
+        <p:txBody>
+          <a:bodyPr wrap="square" anchor="t" lIns="45720" rIns="45720">
+            <a:spAutoFit/>
+          </a:bodyPr>
+          <a:lstStyle/>
+          <a:p>
+            <a:pPr>
+              <a:spcAft>
+                <a:spcPts val="400"/>
+              </a:spcAft>
+            </a:pPr>
+            <a:r>
+              <a:rPr sz="1100" b="0">
+                <a:solidFill>
+                  <a:srgbClr val="1C1A17"/>
+                </a:solidFill>
+                <a:latin typeface="Google Sans Flex"/>
+              </a:rPr>
+              <a:t>Synced every minute with no always-on bot: threads, files, PDFs, screenshots and voice notes. Join: discord.gg/HwSgjmcgF5</a:t>
+            </a:r>
+          </a:p>
+        </p:txBody>
+      </p:sp>
     </p:spTree>
   </p:cSld>
   <p:clrMapOvr>

</xml_diff>

<commit_message>
deck: wider benchmark column, clickable links, drift-scan arrow, wireframes caption, fresh home shot
Co-Authored-By: Claude Opus 5.5 <noreply@anthropic.com>
</commit_message>
<xml_diff>
--- a/deck/canon-deck.pptx
+++ b/deck/canon-deck.pptx
@@ -8278,7 +8278,7 @@
         </p:nvGraphicFramePr>
         <p:xfrm>
           <a:off x="320040" y="1188720"/>
-          <a:ext cx="4754879" cy="2487168"/>
+          <a:ext cx="4754878" cy="2487168"/>
         </p:xfrm>
         <a:graphic>
           <a:graphicData uri="http://schemas.openxmlformats.org/drawingml/2006/table">
@@ -8287,10 +8287,10 @@
                 <a:tableStyleId>{5C22544A-7EE6-4342-B048-85BDC9FD1C3A}</a:tableStyleId>
               </a:tblPr>
               <a:tblGrid>
-                <a:gridCol w="2472537"/>
-                <a:gridCol w="713232"/>
-                <a:gridCol w="950976"/>
+                <a:gridCol w="2187244"/>
                 <a:gridCol w="618134"/>
+                <a:gridCol w="1378915"/>
+                <a:gridCol w="570585"/>
               </a:tblGrid>
               <a:tr h="310896">
                 <a:tc>
@@ -10119,6 +10119,7 @@
                   <a:srgbClr val="1C1A17"/>
                 </a:solidFill>
                 <a:latin typeface="Google Sans Flex"/>
+                <a:hlinkClick r:id="rId5"/>
               </a:rPr>
               <a:t>https://github.com/tejasnafde/canon</a:t>
             </a:r>
@@ -10169,8 +10170,9 @@
                   <a:srgbClr val="1C1A17"/>
                 </a:solidFill>
                 <a:latin typeface="Google Sans Flex"/>
-              </a:rPr>
-              <a:t>https://canon-tn07.web.app  (also https://canon.tn07.dev)</a:t>
+                <a:hlinkClick r:id="rId6"/>
+              </a:rPr>
+              <a:t>https://canon-tn07.web.app</a:t>
             </a:r>
           </a:p>
           <a:p>
@@ -10186,6 +10188,32 @@
                 </a:solidFill>
                 <a:latin typeface="Google Sans Flex"/>
               </a:rPr>
+              <a:t>Same app, custom domain: </a:t>
+            </a:r>
+            <a:r>
+              <a:rPr sz="1400" b="0">
+                <a:solidFill>
+                  <a:srgbClr val="1C1A17"/>
+                </a:solidFill>
+                <a:latin typeface="Google Sans Flex"/>
+                <a:hlinkClick r:id="rId7"/>
+              </a:rPr>
+              <a:t>https://canon.tn07.dev</a:t>
+            </a:r>
+          </a:p>
+          <a:p>
+            <a:pPr>
+              <a:spcAft>
+                <a:spcPts val="1000"/>
+              </a:spcAft>
+            </a:pPr>
+            <a:r>
+              <a:rPr sz="1400" b="1">
+                <a:solidFill>
+                  <a:srgbClr val="1C1A17"/>
+                </a:solidFill>
+                <a:latin typeface="Google Sans Flex"/>
+              </a:rPr>
               <a:t>Cloud Run: </a:t>
             </a:r>
             <a:r>
@@ -10194,6 +10222,7 @@
                   <a:srgbClr val="1C1A17"/>
                 </a:solidFill>
                 <a:latin typeface="Google Sans Flex"/>
+                <a:hlinkClick r:id="rId8"/>
               </a:rPr>
               <a:t>https://canon-ezvux7gqxa-el.a.run.app/health</a:t>
             </a:r>
@@ -10219,6 +10248,7 @@
                   <a:srgbClr val="1C1A17"/>
                 </a:solidFill>
                 <a:latin typeface="Google Sans Flex"/>
+                <a:hlinkClick r:id="rId9"/>
               </a:rPr>
               <a:t>https://discord.gg/HwSgjmcgF5</a:t>
             </a:r>
@@ -10275,7 +10305,7 @@
           <p:nvPr/>
         </p:nvPicPr>
         <p:blipFill>
-          <a:blip r:embed="rId5"/>
+          <a:blip r:embed="rId10"/>
           <a:stretch>
             <a:fillRect/>
           </a:stretch>
@@ -13098,9 +13128,45 @@
           </a:fontRef>
         </p:style>
       </p:cxnSp>
+      <p:cxnSp>
+        <p:nvCxnSpPr>
+          <p:cNvPr id="110" name="Connector 109"/>
+          <p:cNvCxnSpPr/>
+          <p:nvPr/>
+        </p:nvCxnSpPr>
+        <p:spPr>
+          <a:xfrm flipH="1">
+            <a:off x="4023360" y="2167128"/>
+            <a:ext cx="4151376" cy="365760"/>
+          </a:xfrm>
+          <a:prstGeom prst="line">
+            <a:avLst/>
+          </a:prstGeom>
+          <a:ln w="15875">
+            <a:solidFill>
+              <a:srgbClr val="5F5A52"/>
+            </a:solidFill>
+            <a:tailEnd type="triangle" w="med" len="med"/>
+          </a:ln>
+        </p:spPr>
+        <p:style>
+          <a:lnRef idx="2">
+            <a:schemeClr val="accent1"/>
+          </a:lnRef>
+          <a:fillRef idx="0">
+            <a:schemeClr val="accent1"/>
+          </a:fillRef>
+          <a:effectRef idx="1">
+            <a:schemeClr val="accent1"/>
+          </a:effectRef>
+          <a:fontRef idx="minor">
+            <a:schemeClr val="tx1"/>
+          </a:fontRef>
+        </p:style>
+      </p:cxnSp>
       <p:sp>
         <p:nvSpPr>
-          <p:cNvPr id="110" name="TextBox 109"/>
+          <p:cNvPr id="111" name="TextBox 110"/>
           <p:cNvSpPr txBox="1"/>
           <p:nvPr/>
         </p:nvSpPr>
@@ -13139,7 +13205,7 @@
       </p:sp>
       <p:sp>
         <p:nvSpPr>
-          <p:cNvPr id="111" name="Rounded Rectangle 110"/>
+          <p:cNvPr id="112" name="Rounded Rectangle 111"/>
           <p:cNvSpPr/>
           <p:nvPr/>
         </p:nvSpPr>
@@ -13206,7 +13272,7 @@
       </p:sp>
       <p:sp>
         <p:nvSpPr>
-          <p:cNvPr id="112" name="Rounded Rectangle 111"/>
+          <p:cNvPr id="113" name="Rounded Rectangle 112"/>
           <p:cNvSpPr/>
           <p:nvPr/>
         </p:nvSpPr>
@@ -13273,7 +13339,7 @@
       </p:sp>
       <p:sp>
         <p:nvSpPr>
-          <p:cNvPr id="113" name="Rounded Rectangle 112"/>
+          <p:cNvPr id="114" name="Rounded Rectangle 113"/>
           <p:cNvSpPr/>
           <p:nvPr/>
         </p:nvSpPr>
@@ -13340,7 +13406,7 @@
       </p:sp>
       <p:sp>
         <p:nvSpPr>
-          <p:cNvPr id="114" name="Rounded Rectangle 113"/>
+          <p:cNvPr id="115" name="Rounded Rectangle 114"/>
           <p:cNvSpPr/>
           <p:nvPr/>
         </p:nvSpPr>
@@ -13407,7 +13473,7 @@
       </p:sp>
       <p:sp>
         <p:nvSpPr>
-          <p:cNvPr id="115" name="Rounded Rectangle 114"/>
+          <p:cNvPr id="116" name="Rounded Rectangle 115"/>
           <p:cNvSpPr/>
           <p:nvPr/>
         </p:nvSpPr>
@@ -13474,7 +13540,7 @@
       </p:sp>
       <p:sp>
         <p:nvSpPr>
-          <p:cNvPr id="116" name="Rounded Rectangle 115"/>
+          <p:cNvPr id="117" name="Rounded Rectangle 116"/>
           <p:cNvSpPr/>
           <p:nvPr/>
         </p:nvSpPr>
@@ -13541,49 +13607,13 @@
       </p:sp>
       <p:cxnSp>
         <p:nvCxnSpPr>
-          <p:cNvPr id="117" name="Connector 116"/>
-          <p:cNvCxnSpPr/>
-          <p:nvPr/>
-        </p:nvCxnSpPr>
-        <p:spPr>
-          <a:xfrm>
-            <a:off x="1581912" y="3973068"/>
-            <a:ext cx="182880" cy="0"/>
-          </a:xfrm>
-          <a:prstGeom prst="line">
-            <a:avLst/>
-          </a:prstGeom>
-          <a:ln w="15875">
-            <a:solidFill>
-              <a:srgbClr val="5F5A52"/>
-            </a:solidFill>
-            <a:tailEnd type="triangle" w="med" len="med"/>
-          </a:ln>
-        </p:spPr>
-        <p:style>
-          <a:lnRef idx="2">
-            <a:schemeClr val="accent1"/>
-          </a:lnRef>
-          <a:fillRef idx="0">
-            <a:schemeClr val="accent1"/>
-          </a:fillRef>
-          <a:effectRef idx="1">
-            <a:schemeClr val="accent1"/>
-          </a:effectRef>
-          <a:fontRef idx="minor">
-            <a:schemeClr val="tx1"/>
-          </a:fontRef>
-        </p:style>
-      </p:cxnSp>
-      <p:cxnSp>
-        <p:nvCxnSpPr>
           <p:cNvPr id="118" name="Connector 117"/>
           <p:cNvCxnSpPr/>
           <p:nvPr/>
         </p:nvCxnSpPr>
         <p:spPr>
           <a:xfrm>
-            <a:off x="3026664" y="3973068"/>
+            <a:off x="1581912" y="3973068"/>
             <a:ext cx="182880" cy="0"/>
           </a:xfrm>
           <a:prstGeom prst="line">
@@ -13619,7 +13649,7 @@
         </p:nvCxnSpPr>
         <p:spPr>
           <a:xfrm>
-            <a:off x="4471416" y="3973068"/>
+            <a:off x="3026664" y="3973068"/>
             <a:ext cx="182880" cy="0"/>
           </a:xfrm>
           <a:prstGeom prst="line">
@@ -13655,7 +13685,7 @@
         </p:nvCxnSpPr>
         <p:spPr>
           <a:xfrm>
-            <a:off x="5916168" y="3973068"/>
+            <a:off x="4471416" y="3973068"/>
             <a:ext cx="182880" cy="0"/>
           </a:xfrm>
           <a:prstGeom prst="line">
@@ -13691,7 +13721,7 @@
         </p:nvCxnSpPr>
         <p:spPr>
           <a:xfrm>
-            <a:off x="7360920" y="3973068"/>
+            <a:off x="5916168" y="3973068"/>
             <a:ext cx="182880" cy="0"/>
           </a:xfrm>
           <a:prstGeom prst="line">
@@ -13722,6 +13752,42 @@
       <p:cxnSp>
         <p:nvCxnSpPr>
           <p:cNvPr id="122" name="Connector 121"/>
+          <p:cNvCxnSpPr/>
+          <p:nvPr/>
+        </p:nvCxnSpPr>
+        <p:spPr>
+          <a:xfrm>
+            <a:off x="7360920" y="3973068"/>
+            <a:ext cx="182880" cy="0"/>
+          </a:xfrm>
+          <a:prstGeom prst="line">
+            <a:avLst/>
+          </a:prstGeom>
+          <a:ln w="15875">
+            <a:solidFill>
+              <a:srgbClr val="5F5A52"/>
+            </a:solidFill>
+            <a:tailEnd type="triangle" w="med" len="med"/>
+          </a:ln>
+        </p:spPr>
+        <p:style>
+          <a:lnRef idx="2">
+            <a:schemeClr val="accent1"/>
+          </a:lnRef>
+          <a:fillRef idx="0">
+            <a:schemeClr val="accent1"/>
+          </a:fillRef>
+          <a:effectRef idx="1">
+            <a:schemeClr val="accent1"/>
+          </a:effectRef>
+          <a:fontRef idx="minor">
+            <a:schemeClr val="tx1"/>
+          </a:fontRef>
+        </p:style>
+      </p:cxnSp>
+      <p:cxnSp>
+        <p:nvCxnSpPr>
+          <p:cNvPr id="123" name="Connector 122"/>
           <p:cNvCxnSpPr/>
           <p:nvPr/>
         </p:nvCxnSpPr>
@@ -13930,9 +13996,48 @@
           </a:p>
         </p:txBody>
       </p:sp>
+      <p:sp>
+        <p:nvSpPr>
+          <p:cNvPr id="104" name="TextBox 103"/>
+          <p:cNvSpPr txBox="1"/>
+          <p:nvPr/>
+        </p:nvSpPr>
+        <p:spPr>
+          <a:xfrm>
+            <a:off x="320040" y="4800600"/>
+            <a:ext cx="8503920" cy="274320"/>
+          </a:xfrm>
+          <a:prstGeom prst="rect">
+            <a:avLst/>
+          </a:prstGeom>
+          <a:noFill/>
+        </p:spPr>
+        <p:txBody>
+          <a:bodyPr wrap="square" anchor="t" lIns="45720" rIns="45720">
+            <a:spAutoFit/>
+          </a:bodyPr>
+          <a:lstStyle/>
+          <a:p>
+            <a:pPr>
+              <a:spcAft>
+                <a:spcPts val="400"/>
+              </a:spcAft>
+            </a:pPr>
+            <a:r>
+              <a:rPr sz="1000" b="0">
+                <a:solidFill>
+                  <a:srgbClr val="5F5A52"/>
+                </a:solidFill>
+                <a:latin typeface="Google Sans Flex"/>
+              </a:rPr>
+              <a:t>Early wireframes: the approved mocks the web app was built from. The live app (current numbers) is on the Snapshots slide.</a:t>
+            </a:r>
+          </a:p>
+        </p:txBody>
+      </p:sp>
       <p:pic>
         <p:nvPicPr>
-          <p:cNvPr id="104" name="Picture 103" descr="home.jpg"/>
+          <p:cNvPr id="105" name="Picture 104" descr="home.jpg"/>
           <p:cNvPicPr>
             <a:picLocks noChangeAspect="1"/>
           </p:cNvPicPr>
@@ -13961,7 +14066,7 @@
       </p:pic>
       <p:sp>
         <p:nvSpPr>
-          <p:cNvPr id="105" name="TextBox 104"/>
+          <p:cNvPr id="106" name="TextBox 105"/>
           <p:cNvSpPr txBox="1"/>
           <p:nvPr/>
         </p:nvSpPr>
@@ -14000,7 +14105,7 @@
       </p:sp>
       <p:pic>
         <p:nvPicPr>
-          <p:cNvPr id="106" name="Picture 105" descr="new-hire.jpg"/>
+          <p:cNvPr id="107" name="Picture 106" descr="new-hire.jpg"/>
           <p:cNvPicPr>
             <a:picLocks noChangeAspect="1"/>
           </p:cNvPicPr>
@@ -14029,7 +14134,7 @@
       </p:pic>
       <p:sp>
         <p:nvSpPr>
-          <p:cNvPr id="107" name="TextBox 106"/>
+          <p:cNvPr id="108" name="TextBox 107"/>
           <p:cNvSpPr txBox="1"/>
           <p:nvPr/>
         </p:nvSpPr>
@@ -14068,7 +14173,7 @@
       </p:sp>
       <p:pic>
         <p:nvPicPr>
-          <p:cNvPr id="108" name="Picture 107" descr="agent.jpg"/>
+          <p:cNvPr id="109" name="Picture 108" descr="agent.jpg"/>
           <p:cNvPicPr>
             <a:picLocks noChangeAspect="1"/>
           </p:cNvPicPr>
@@ -14097,7 +14202,7 @@
       </p:pic>
       <p:sp>
         <p:nvSpPr>
-          <p:cNvPr id="109" name="TextBox 108"/>
+          <p:cNvPr id="110" name="TextBox 109"/>
           <p:cNvSpPr txBox="1"/>
           <p:nvPr/>
         </p:nvSpPr>

</xml_diff>

<commit_message>
Discord: answer questions in channels (guard for can-I, Ask why otherwise, silent when unanswerable unless mentioned); deck reply screenshot
Co-Authored-By: Claude Opus 5.5 <noreply@anthropic.com>
</commit_message>
<xml_diff>
--- a/deck/canon-deck.pptx
+++ b/deck/canon-deck.pptx
@@ -10628,15 +10628,83 @@
           </a:p>
         </p:txBody>
       </p:sp>
+      <p:pic>
+        <p:nvPicPr>
+          <p:cNvPr id="142" name="Picture 141" descr="4-reply.jpg"/>
+          <p:cNvPicPr>
+            <a:picLocks noChangeAspect="1"/>
+          </p:cNvPicPr>
+          <p:nvPr/>
+        </p:nvPicPr>
+        <p:blipFill>
+          <a:blip r:embed="rId5"/>
+          <a:stretch>
+            <a:fillRect/>
+          </a:stretch>
+        </p:blipFill>
+        <p:spPr>
+          <a:xfrm>
+            <a:off x="320040" y="3846953"/>
+            <a:ext cx="2743200" cy="1038610"/>
+          </a:xfrm>
+          <a:prstGeom prst="rect">
+            <a:avLst/>
+          </a:prstGeom>
+          <a:ln w="9525">
+            <a:solidFill>
+              <a:srgbClr val="D8CFBE"/>
+            </a:solidFill>
+          </a:ln>
+        </p:spPr>
+      </p:pic>
       <p:sp>
         <p:nvSpPr>
-          <p:cNvPr id="142" name="TextBox 141"/>
+          <p:cNvPr id="143" name="TextBox 142"/>
           <p:cNvSpPr txBox="1"/>
           <p:nvPr/>
         </p:nvSpPr>
         <p:spPr>
           <a:xfrm>
-            <a:off x="320040" y="3520440"/>
+            <a:off x="320040" y="5303518"/>
+            <a:ext cx="2743200" cy="274320"/>
+          </a:xfrm>
+          <a:prstGeom prst="rect">
+            <a:avLst/>
+          </a:prstGeom>
+          <a:noFill/>
+        </p:spPr>
+        <p:txBody>
+          <a:bodyPr wrap="square" anchor="t" lIns="45720" rIns="45720">
+            <a:spAutoFit/>
+          </a:bodyPr>
+          <a:lstStyle/>
+          <a:p>
+            <a:pPr algn="ctr">
+              <a:spcAft>
+                <a:spcPts val="400"/>
+              </a:spcAft>
+            </a:pPr>
+            <a:r>
+              <a:rPr sz="900" b="0">
+                <a:solidFill>
+                  <a:srgbClr val="5F5A52"/>
+                </a:solidFill>
+                <a:latin typeface="Google Sans Flex"/>
+              </a:rPr>
+              <a:t>Canon replies under a message that breaks a decision</a:t>
+            </a:r>
+          </a:p>
+        </p:txBody>
+      </p:sp>
+      <p:sp>
+        <p:nvSpPr>
+          <p:cNvPr id="144" name="TextBox 143"/>
+          <p:cNvSpPr txBox="1"/>
+          <p:nvPr/>
+        </p:nvSpPr>
+        <p:spPr>
+          <a:xfrm>
+            <a:off x="320040" y="5669280"/>
             <a:ext cx="8503920" cy="548640"/>
           </a:xfrm>
           <a:prstGeom prst="rect">

</xml_diff>

<commit_message>
deck: Discord slide as a 2x2 grid with the live reply first
Co-Authored-By: Claude Opus 5.5 <noreply@anthropic.com>
</commit_message>
<xml_diff>
--- a/deck/canon-deck.pptx
+++ b/deck/canon-deck.pptx
@@ -10426,7 +10426,7 @@
       </p:sp>
       <p:pic>
         <p:nvPicPr>
-          <p:cNvPr id="136" name="Picture 135" descr="1-general.jpg"/>
+          <p:cNvPr id="136" name="Picture 135" descr="0-reply.jpg"/>
           <p:cNvPicPr>
             <a:picLocks noChangeAspect="1"/>
           </p:cNvPicPr>
@@ -10440,8 +10440,8 @@
         </p:blipFill>
         <p:spPr>
           <a:xfrm>
-            <a:off x="320040" y="1455855"/>
-            <a:ext cx="2743200" cy="1340249"/>
+            <a:off x="320040" y="1201207"/>
+            <a:ext cx="4160520" cy="1575225"/>
           </a:xfrm>
           <a:prstGeom prst="rect">
             <a:avLst/>
@@ -10461,8 +10461,8 @@
         </p:nvSpPr>
         <p:spPr>
           <a:xfrm>
-            <a:off x="320040" y="3063239"/>
-            <a:ext cx="2743200" cy="274320"/>
+            <a:off x="320040" y="2788920"/>
+            <a:ext cx="4160520" cy="274320"/>
           </a:xfrm>
           <a:prstGeom prst="rect">
             <a:avLst/>
@@ -10487,14 +10487,14 @@
                 </a:solidFill>
                 <a:latin typeface="Google Sans Flex"/>
               </a:rPr>
-              <a:t>Threads in #general, posted as the people who wrote them</a:t>
+              <a:t>A real post at 21:14; Canon replied in about a minute. Join: discord.gg/HwSgjmcgF5</a:t>
             </a:r>
           </a:p>
         </p:txBody>
       </p:sp>
       <p:pic>
         <p:nvPicPr>
-          <p:cNvPr id="138" name="Picture 137" descr="2-engineering.jpg"/>
+          <p:cNvPr id="138" name="Picture 137" descr="1-general.jpg"/>
           <p:cNvPicPr>
             <a:picLocks noChangeAspect="1"/>
           </p:cNvPicPr>
@@ -10508,8 +10508,8 @@
         </p:blipFill>
         <p:spPr>
           <a:xfrm>
-            <a:off x="3200400" y="1461733"/>
-            <a:ext cx="2743200" cy="1328492"/>
+            <a:off x="5106068" y="1188720"/>
+            <a:ext cx="3275263" cy="1600200"/>
           </a:xfrm>
           <a:prstGeom prst="rect">
             <a:avLst/>
@@ -10529,8 +10529,8 @@
         </p:nvSpPr>
         <p:spPr>
           <a:xfrm>
-            <a:off x="3200400" y="3063239"/>
-            <a:ext cx="2743200" cy="274320"/>
+            <a:off x="4663440" y="2788920"/>
+            <a:ext cx="4160520" cy="274320"/>
           </a:xfrm>
           <a:prstGeom prst="rect">
             <a:avLst/>
@@ -10555,14 +10555,14 @@
                 </a:solidFill>
                 <a:latin typeface="Google Sans Flex"/>
               </a:rPr>
-              <a:t>#engineering: the stale Friday release window, as a screenshot</a:t>
+              <a:t>Threads in #general, posted as the people who wrote them</a:t>
             </a:r>
           </a:p>
         </p:txBody>
       </p:sp>
       <p:pic>
         <p:nvPicPr>
-          <p:cNvPr id="140" name="Picture 139" descr="3-sales.jpg"/>
+          <p:cNvPr id="140" name="Picture 139" descr="2-engineering.jpg"/>
           <p:cNvPicPr>
             <a:picLocks noChangeAspect="1"/>
           </p:cNvPicPr>
@@ -10576,8 +10576,8 @@
         </p:blipFill>
         <p:spPr>
           <a:xfrm>
-            <a:off x="6080760" y="1343188"/>
-            <a:ext cx="2743200" cy="1565583"/>
+            <a:off x="748176" y="3200400"/>
+            <a:ext cx="3304247" cy="1600200"/>
           </a:xfrm>
           <a:prstGeom prst="rect">
             <a:avLst/>
@@ -10597,8 +10597,8 @@
         </p:nvSpPr>
         <p:spPr>
           <a:xfrm>
-            <a:off x="6080760" y="3063239"/>
-            <a:ext cx="2743200" cy="274320"/>
+            <a:off x="320040" y="4800600"/>
+            <a:ext cx="4160520" cy="274320"/>
           </a:xfrm>
           <a:prstGeom prst="rect">
             <a:avLst/>
@@ -10623,14 +10623,14 @@
                 </a:solidFill>
                 <a:latin typeface="Google Sans Flex"/>
               </a:rPr>
-              <a:t>#sales: the old USD 99 pricing page and the sales FAQ file</a:t>
+              <a:t>#engineering: the stale Friday release window, as a screenshot</a:t>
             </a:r>
           </a:p>
         </p:txBody>
       </p:sp>
       <p:pic>
         <p:nvPicPr>
-          <p:cNvPr id="142" name="Picture 141" descr="4-reply.jpg"/>
+          <p:cNvPr id="142" name="Picture 141" descr="3-sales.jpg"/>
           <p:cNvPicPr>
             <a:picLocks noChangeAspect="1"/>
           </p:cNvPicPr>
@@ -10644,8 +10644,8 @@
         </p:blipFill>
         <p:spPr>
           <a:xfrm>
-            <a:off x="320040" y="3846953"/>
-            <a:ext cx="2743200" cy="1038610"/>
+            <a:off x="5341773" y="3200400"/>
+            <a:ext cx="2803854" cy="1600200"/>
           </a:xfrm>
           <a:prstGeom prst="rect">
             <a:avLst/>
@@ -10665,8 +10665,8 @@
         </p:nvSpPr>
         <p:spPr>
           <a:xfrm>
-            <a:off x="320040" y="5303518"/>
-            <a:ext cx="2743200" cy="274320"/>
+            <a:off x="4663440" y="4800600"/>
+            <a:ext cx="4160520" cy="274320"/>
           </a:xfrm>
           <a:prstGeom prst="rect">
             <a:avLst/>
@@ -10691,46 +10691,7 @@
                 </a:solidFill>
                 <a:latin typeface="Google Sans Flex"/>
               </a:rPr>
-              <a:t>Canon replies under a message that breaks a decision</a:t>
-            </a:r>
-          </a:p>
-        </p:txBody>
-      </p:sp>
-      <p:sp>
-        <p:nvSpPr>
-          <p:cNvPr id="144" name="TextBox 143"/>
-          <p:cNvSpPr txBox="1"/>
-          <p:nvPr/>
-        </p:nvSpPr>
-        <p:spPr>
-          <a:xfrm>
-            <a:off x="320040" y="5669280"/>
-            <a:ext cx="8503920" cy="548640"/>
-          </a:xfrm>
-          <a:prstGeom prst="rect">
-            <a:avLst/>
-          </a:prstGeom>
-          <a:noFill/>
-        </p:spPr>
-        <p:txBody>
-          <a:bodyPr wrap="square" anchor="t" lIns="45720" rIns="45720">
-            <a:spAutoFit/>
-          </a:bodyPr>
-          <a:lstStyle/>
-          <a:p>
-            <a:pPr>
-              <a:spcAft>
-                <a:spcPts val="400"/>
-              </a:spcAft>
-            </a:pPr>
-            <a:r>
-              <a:rPr sz="1100" b="0">
-                <a:solidFill>
-                  <a:srgbClr val="1C1A17"/>
-                </a:solidFill>
-                <a:latin typeface="Google Sans Flex"/>
-              </a:rPr>
-              <a:t>Synced every minute with no always-on bot: threads, files, PDFs, screenshots and voice notes. Join: discord.gg/HwSgjmcgF5</a:t>
+              <a:t>#sales: the old USD 99 pricing page and the sales FAQ file</a:t>
             </a:r>
           </a:p>
         </p:txBody>

</xml_diff>

<commit_message>
Demo video link in deck and README
Co-Authored-By: Claude Opus 5.5 <noreply@anthropic.com>
</commit_message>
<xml_diff>
--- a/deck/canon-deck.pptx
+++ b/deck/canon-deck.pptx
@@ -10145,8 +10145,9 @@
                   <a:srgbClr val="1C1A17"/>
                 </a:solidFill>
                 <a:latin typeface="Google Sans Flex"/>
-              </a:rPr>
-              <a:t>(add the video link)</a:t>
+                <a:hlinkClick r:id="rId6"/>
+              </a:rPr>
+              <a:t>https://youtu.be/tPJenhhhjI8</a:t>
             </a:r>
           </a:p>
           <a:p>
@@ -10170,7 +10171,7 @@
                   <a:srgbClr val="1C1A17"/>
                 </a:solidFill>
                 <a:latin typeface="Google Sans Flex"/>
-                <a:hlinkClick r:id="rId6"/>
+                <a:hlinkClick r:id="rId7"/>
               </a:rPr>
               <a:t>https://canon-tn07.web.app</a:t>
             </a:r>
@@ -10196,7 +10197,7 @@
                   <a:srgbClr val="1C1A17"/>
                 </a:solidFill>
                 <a:latin typeface="Google Sans Flex"/>
-                <a:hlinkClick r:id="rId7"/>
+                <a:hlinkClick r:id="rId8"/>
               </a:rPr>
               <a:t>https://canon.tn07.dev</a:t>
             </a:r>
@@ -10222,7 +10223,7 @@
                   <a:srgbClr val="1C1A17"/>
                 </a:solidFill>
                 <a:latin typeface="Google Sans Flex"/>
-                <a:hlinkClick r:id="rId8"/>
+                <a:hlinkClick r:id="rId9"/>
               </a:rPr>
               <a:t>https://canon-ezvux7gqxa-el.a.run.app/health</a:t>
             </a:r>
@@ -10248,7 +10249,7 @@
                   <a:srgbClr val="1C1A17"/>
                 </a:solidFill>
                 <a:latin typeface="Google Sans Flex"/>
-                <a:hlinkClick r:id="rId9"/>
+                <a:hlinkClick r:id="rId10"/>
               </a:rPr>
               <a:t>https://discord.gg/HwSgjmcgF5</a:t>
             </a:r>
@@ -10305,7 +10306,7 @@
           <p:nvPr/>
         </p:nvPicPr>
         <p:blipFill>
-          <a:blip r:embed="rId10"/>
+          <a:blip r:embed="rId11"/>
           <a:stretch>
             <a:fillRect/>
           </a:stretch>

</xml_diff>